<commit_message>
edit outliers, modelos, sma, Rstudio
</commit_message>
<xml_diff>
--- a/RESULTADOS.pptx
+++ b/RESULTADOS.pptx
@@ -13,10 +13,10 @@
     <p:sldId id="262" r:id="rId4"/>
     <p:sldId id="264" r:id="rId5"/>
     <p:sldId id="257" r:id="rId6"/>
-    <p:sldId id="260" r:id="rId7"/>
-    <p:sldId id="266" r:id="rId8"/>
-    <p:sldId id="258" r:id="rId9"/>
-    <p:sldId id="265" r:id="rId10"/>
+    <p:sldId id="270" r:id="rId7"/>
+    <p:sldId id="260" r:id="rId8"/>
+    <p:sldId id="266" r:id="rId9"/>
+    <p:sldId id="269" r:id="rId10"/>
   </p:sldIdLst>
   <p:sldSz cx="12192000" cy="6858000"/>
   <p:notesSz cx="6858000" cy="9144000"/>
@@ -216,7 +216,7 @@
           <a:p>
             <a:fld id="{F7988E1C-9E16-4837-8FE7-B15F160F0F0C}" type="datetimeFigureOut">
               <a:rPr lang="en-US" smtClean="0"/>
-              <a:t>3/24/2026</a:t>
+              <a:t>4/7/2026</a:t>
             </a:fld>
             <a:endParaRPr lang="en-US"/>
           </a:p>
@@ -626,195 +626,19 @@
           <a:p>
             <a:r>
               <a:rPr lang="es-MX" dirty="0" smtClean="0"/>
-              <a:t>SMA</a:t>
+              <a:t>DUMMIES.</a:t>
             </a:r>
             <a:r>
               <a:rPr lang="es-MX" baseline="0" dirty="0" smtClean="0"/>
-              <a:t> </a:t>
+              <a:t> La interpretación del </a:t>
             </a:r>
             <a:r>
               <a:rPr lang="es-MX" baseline="0" dirty="0" err="1" smtClean="0"/>
-              <a:t>correlation</a:t>
+              <a:t>NxP</a:t>
             </a:r>
             <a:r>
               <a:rPr lang="es-MX" baseline="0" dirty="0" smtClean="0"/>
-              <a:t> </a:t>
-            </a:r>
-            <a:r>
-              <a:rPr lang="es-MX" baseline="0" dirty="0" err="1" smtClean="0"/>
-              <a:t>between</a:t>
-            </a:r>
-            <a:r>
-              <a:rPr lang="es-MX" baseline="0" dirty="0" smtClean="0"/>
-              <a:t> variables. </a:t>
-            </a:r>
-            <a:r>
-              <a:rPr lang="en-US" dirty="0" smtClean="0"/>
-              <a:t>Scaling relationships between </a:t>
-            </a:r>
-            <a:r>
-              <a:rPr lang="en-US" dirty="0" err="1" smtClean="0"/>
-              <a:t>Asat</a:t>
-            </a:r>
-            <a:r>
-              <a:rPr lang="en-US" dirty="0" smtClean="0"/>
-              <a:t> and leaf nutrients were assessed using standardized major axis (SMA) </a:t>
-            </a:r>
-            <a:r>
-              <a:rPr lang="en-US" dirty="0" err="1" smtClean="0"/>
-              <a:t>regres</a:t>
-            </a:r>
-            <a:r>
-              <a:rPr lang="en-US" dirty="0" smtClean="0"/>
-              <a:t>- </a:t>
-            </a:r>
-            <a:r>
-              <a:rPr lang="en-US" dirty="0" err="1" smtClean="0"/>
-              <a:t>sion</a:t>
-            </a:r>
-            <a:r>
-              <a:rPr lang="en-US" dirty="0" smtClean="0"/>
-              <a:t> (Wright et al. 2004; Warton et al. 2006; </a:t>
-            </a:r>
-            <a:r>
-              <a:rPr lang="en-US" dirty="0" err="1" smtClean="0"/>
-              <a:t>Mantlana</a:t>
-            </a:r>
-            <a:r>
-              <a:rPr lang="en-US" dirty="0" smtClean="0"/>
-              <a:t> et al. 2008). SMA regression is a regression method preferred when one is more interested in the true slope of a relation- ship, rather than predicting values for a dependent variable from a predictor variable. It is thus commonly used to establish </a:t>
-            </a:r>
-            <a:r>
-              <a:rPr lang="en-US" dirty="0" err="1" smtClean="0"/>
-              <a:t>allometric</a:t>
-            </a:r>
-            <a:r>
-              <a:rPr lang="en-US" dirty="0" smtClean="0"/>
-              <a:t> scaling relationships, especially when the two variables are not measured on comparable scales (Warton et al. 2006). All statistical analyses were done in </a:t>
-            </a:r>
-            <a:r>
-              <a:rPr lang="en-US" dirty="0" err="1" smtClean="0"/>
-              <a:t>RStudio</a:t>
-            </a:r>
-            <a:r>
-              <a:rPr lang="en-US" dirty="0" smtClean="0"/>
-              <a:t> (V 1.1.456).</a:t>
-            </a:r>
-          </a:p>
-          <a:p>
-            <a:r>
-              <a:rPr lang="es-MX" dirty="0" err="1" smtClean="0"/>
-              <a:t>Graphic</a:t>
-            </a:r>
-            <a:r>
-              <a:rPr lang="es-MX" dirty="0" smtClean="0"/>
-              <a:t> to </a:t>
-            </a:r>
-            <a:r>
-              <a:rPr lang="es-MX" dirty="0" err="1" smtClean="0"/>
-              <a:t>depict</a:t>
-            </a:r>
-            <a:r>
-              <a:rPr lang="es-MX" baseline="0" dirty="0" smtClean="0"/>
-              <a:t> </a:t>
-            </a:r>
-            <a:r>
-              <a:rPr lang="es-MX" baseline="0" dirty="0" err="1" smtClean="0"/>
-              <a:t>that</a:t>
-            </a:r>
-            <a:r>
-              <a:rPr lang="es-MX" baseline="0" dirty="0" smtClean="0"/>
-              <a:t> </a:t>
-            </a:r>
-            <a:r>
-              <a:rPr lang="es-MX" baseline="0" dirty="0" err="1" smtClean="0"/>
-              <a:t>although</a:t>
-            </a:r>
-            <a:r>
-              <a:rPr lang="es-MX" baseline="0" dirty="0" smtClean="0"/>
-              <a:t> </a:t>
-            </a:r>
-            <a:r>
-              <a:rPr lang="es-MX" baseline="0" dirty="0" err="1" smtClean="0"/>
-              <a:t>nutrients</a:t>
-            </a:r>
-            <a:r>
-              <a:rPr lang="es-MX" baseline="0" dirty="0" smtClean="0"/>
-              <a:t> are </a:t>
-            </a:r>
-            <a:r>
-              <a:rPr lang="es-MX" baseline="0" dirty="0" err="1" smtClean="0"/>
-              <a:t>not</a:t>
-            </a:r>
-            <a:r>
-              <a:rPr lang="es-MX" baseline="0" dirty="0" smtClean="0"/>
-              <a:t> </a:t>
-            </a:r>
-            <a:r>
-              <a:rPr lang="es-MX" baseline="0" dirty="0" err="1" smtClean="0"/>
-              <a:t>enough</a:t>
-            </a:r>
-            <a:r>
-              <a:rPr lang="es-MX" baseline="0" dirty="0" smtClean="0"/>
-              <a:t> to </a:t>
-            </a:r>
-            <a:r>
-              <a:rPr lang="es-MX" baseline="0" dirty="0" err="1" smtClean="0"/>
-              <a:t>see</a:t>
-            </a:r>
-            <a:r>
-              <a:rPr lang="es-MX" baseline="0" dirty="0" smtClean="0"/>
-              <a:t> </a:t>
-            </a:r>
-            <a:r>
-              <a:rPr lang="es-MX" baseline="0" dirty="0" err="1" smtClean="0"/>
-              <a:t>shifts</a:t>
-            </a:r>
-            <a:r>
-              <a:rPr lang="es-MX" baseline="0" dirty="0" smtClean="0"/>
-              <a:t>. At 2000 and 3000 </a:t>
-            </a:r>
-            <a:r>
-              <a:rPr lang="es-MX" baseline="0" dirty="0" err="1" smtClean="0"/>
-              <a:t>the</a:t>
-            </a:r>
-            <a:r>
-              <a:rPr lang="es-MX" baseline="0" dirty="0" smtClean="0"/>
-              <a:t> responses are more similar. </a:t>
-            </a:r>
-          </a:p>
-          <a:p>
-            <a:r>
-              <a:rPr lang="es-MX" baseline="0" dirty="0" err="1" smtClean="0"/>
-              <a:t>Pouteria</a:t>
-            </a:r>
-            <a:r>
-              <a:rPr lang="es-MX" baseline="0" dirty="0" smtClean="0"/>
-              <a:t>, </a:t>
-            </a:r>
-            <a:r>
-              <a:rPr lang="es-MX" baseline="0" dirty="0" err="1" smtClean="0"/>
-              <a:t>Hedyosmum</a:t>
-            </a:r>
-            <a:r>
-              <a:rPr lang="es-MX" baseline="0" dirty="0" smtClean="0"/>
-              <a:t> y </a:t>
-            </a:r>
-            <a:r>
-              <a:rPr lang="es-MX" baseline="0" dirty="0" err="1" smtClean="0"/>
-              <a:t>Weinmania</a:t>
-            </a:r>
-            <a:r>
-              <a:rPr lang="es-MX" baseline="0" dirty="0" smtClean="0"/>
-              <a:t> tienen resultados que se pueden discutir. Solo en estas </a:t>
-            </a:r>
-            <a:r>
-              <a:rPr lang="es-MX" baseline="0" dirty="0" err="1" smtClean="0"/>
-              <a:t>Narea</a:t>
-            </a:r>
-            <a:r>
-              <a:rPr lang="es-MX" baseline="0" dirty="0" smtClean="0"/>
-              <a:t> funciona como predictor, pero no necesariamente en todas. </a:t>
+              <a:t> es diferente. Antagonismo </a:t>
             </a:r>
             <a:endParaRPr lang="en-US" dirty="0"/>
           </a:p>
@@ -846,7 +670,7 @@
     </p:spTree>
     <p:extLst>
       <p:ext uri="{BB962C8B-B14F-4D97-AF65-F5344CB8AC3E}">
-        <p14:creationId xmlns:p14="http://schemas.microsoft.com/office/powerpoint/2010/main" val="3702535326"/>
+        <p14:creationId xmlns:p14="http://schemas.microsoft.com/office/powerpoint/2010/main" val="4294197314"/>
       </p:ext>
     </p:extLst>
   </p:cSld>
@@ -900,6 +724,198 @@
           <a:bodyPr/>
           <a:lstStyle/>
           <a:p>
+            <a:r>
+              <a:rPr lang="es-MX" dirty="0" smtClean="0"/>
+              <a:t>SMA</a:t>
+            </a:r>
+            <a:r>
+              <a:rPr lang="es-MX" baseline="0" dirty="0" smtClean="0"/>
+              <a:t> </a:t>
+            </a:r>
+            <a:r>
+              <a:rPr lang="es-MX" baseline="0" dirty="0" err="1" smtClean="0"/>
+              <a:t>correlation</a:t>
+            </a:r>
+            <a:r>
+              <a:rPr lang="es-MX" baseline="0" dirty="0" smtClean="0"/>
+              <a:t> </a:t>
+            </a:r>
+            <a:r>
+              <a:rPr lang="es-MX" baseline="0" dirty="0" err="1" smtClean="0"/>
+              <a:t>between</a:t>
+            </a:r>
+            <a:r>
+              <a:rPr lang="es-MX" baseline="0" dirty="0" smtClean="0"/>
+              <a:t> variables. </a:t>
+            </a:r>
+            <a:r>
+              <a:rPr lang="en-US" dirty="0" smtClean="0"/>
+              <a:t>Scaling relationships between </a:t>
+            </a:r>
+            <a:r>
+              <a:rPr lang="en-US" dirty="0" err="1" smtClean="0"/>
+              <a:t>Asat</a:t>
+            </a:r>
+            <a:r>
+              <a:rPr lang="en-US" dirty="0" smtClean="0"/>
+              <a:t> and leaf nutrients were assessed using standardized major axis (SMA) </a:t>
+            </a:r>
+            <a:r>
+              <a:rPr lang="en-US" dirty="0" err="1" smtClean="0"/>
+              <a:t>regres</a:t>
+            </a:r>
+            <a:r>
+              <a:rPr lang="en-US" dirty="0" smtClean="0"/>
+              <a:t>- </a:t>
+            </a:r>
+            <a:r>
+              <a:rPr lang="en-US" dirty="0" err="1" smtClean="0"/>
+              <a:t>sion</a:t>
+            </a:r>
+            <a:r>
+              <a:rPr lang="en-US" dirty="0" smtClean="0"/>
+              <a:t> (Wright et al. 2004; Warton et al. 2006; </a:t>
+            </a:r>
+            <a:r>
+              <a:rPr lang="en-US" dirty="0" err="1" smtClean="0"/>
+              <a:t>Mantlana</a:t>
+            </a:r>
+            <a:r>
+              <a:rPr lang="en-US" dirty="0" smtClean="0"/>
+              <a:t> et al. 2008). SMA regression is a regression method preferred when one is more interested in the true slope of a relation- ship, rather than predicting values for a dependent variable from a predictor variable. It is thus commonly used to establish </a:t>
+            </a:r>
+            <a:r>
+              <a:rPr lang="en-US" dirty="0" err="1" smtClean="0"/>
+              <a:t>allometric</a:t>
+            </a:r>
+            <a:r>
+              <a:rPr lang="en-US" dirty="0" smtClean="0"/>
+              <a:t> scaling relationships, especially when the two variables are not measured on comparable scales (Warton et al. 2006). All statistical analyses were done in </a:t>
+            </a:r>
+            <a:r>
+              <a:rPr lang="en-US" dirty="0" err="1" smtClean="0"/>
+              <a:t>RStudio</a:t>
+            </a:r>
+            <a:r>
+              <a:rPr lang="en-US" dirty="0" smtClean="0"/>
+              <a:t> (V 1.1.456).</a:t>
+            </a:r>
+          </a:p>
+          <a:p>
+            <a:r>
+              <a:rPr lang="es-MX" dirty="0" err="1" smtClean="0"/>
+              <a:t>Graphic</a:t>
+            </a:r>
+            <a:r>
+              <a:rPr lang="es-MX" dirty="0" smtClean="0"/>
+              <a:t> to </a:t>
+            </a:r>
+            <a:r>
+              <a:rPr lang="es-MX" dirty="0" err="1" smtClean="0"/>
+              <a:t>depict</a:t>
+            </a:r>
+            <a:r>
+              <a:rPr lang="es-MX" baseline="0" dirty="0" smtClean="0"/>
+              <a:t> </a:t>
+            </a:r>
+            <a:r>
+              <a:rPr lang="es-MX" baseline="0" dirty="0" err="1" smtClean="0"/>
+              <a:t>that</a:t>
+            </a:r>
+            <a:r>
+              <a:rPr lang="es-MX" baseline="0" dirty="0" smtClean="0"/>
+              <a:t> </a:t>
+            </a:r>
+            <a:r>
+              <a:rPr lang="es-MX" baseline="0" dirty="0" err="1" smtClean="0"/>
+              <a:t>although</a:t>
+            </a:r>
+            <a:r>
+              <a:rPr lang="es-MX" baseline="0" dirty="0" smtClean="0"/>
+              <a:t> </a:t>
+            </a:r>
+            <a:r>
+              <a:rPr lang="es-MX" baseline="0" dirty="0" err="1" smtClean="0"/>
+              <a:t>nutrients</a:t>
+            </a:r>
+            <a:r>
+              <a:rPr lang="es-MX" baseline="0" dirty="0" smtClean="0"/>
+              <a:t> are </a:t>
+            </a:r>
+            <a:r>
+              <a:rPr lang="es-MX" baseline="0" dirty="0" err="1" smtClean="0"/>
+              <a:t>not</a:t>
+            </a:r>
+            <a:r>
+              <a:rPr lang="es-MX" baseline="0" dirty="0" smtClean="0"/>
+              <a:t> </a:t>
+            </a:r>
+            <a:r>
+              <a:rPr lang="es-MX" baseline="0" dirty="0" err="1" smtClean="0"/>
+              <a:t>enough</a:t>
+            </a:r>
+            <a:r>
+              <a:rPr lang="es-MX" baseline="0" dirty="0" smtClean="0"/>
+              <a:t> to </a:t>
+            </a:r>
+            <a:r>
+              <a:rPr lang="es-MX" baseline="0" dirty="0" err="1" smtClean="0"/>
+              <a:t>see</a:t>
+            </a:r>
+            <a:r>
+              <a:rPr lang="es-MX" baseline="0" dirty="0" smtClean="0"/>
+              <a:t> </a:t>
+            </a:r>
+            <a:r>
+              <a:rPr lang="es-MX" baseline="0" dirty="0" err="1" smtClean="0"/>
+              <a:t>shifts</a:t>
+            </a:r>
+            <a:r>
+              <a:rPr lang="es-MX" baseline="0" dirty="0" smtClean="0"/>
+              <a:t>. At 2000 and 3000 </a:t>
+            </a:r>
+            <a:r>
+              <a:rPr lang="es-MX" baseline="0" dirty="0" err="1" smtClean="0"/>
+              <a:t>the</a:t>
+            </a:r>
+            <a:r>
+              <a:rPr lang="es-MX" baseline="0" dirty="0" smtClean="0"/>
+              <a:t> responses are more similar. </a:t>
+            </a:r>
+          </a:p>
+          <a:p>
+            <a:r>
+              <a:rPr lang="es-MX" baseline="0" dirty="0" err="1" smtClean="0"/>
+              <a:t>Pouteria</a:t>
+            </a:r>
+            <a:r>
+              <a:rPr lang="es-MX" baseline="0" dirty="0" smtClean="0"/>
+              <a:t>, </a:t>
+            </a:r>
+            <a:r>
+              <a:rPr lang="es-MX" baseline="0" dirty="0" err="1" smtClean="0"/>
+              <a:t>Hedyosmum</a:t>
+            </a:r>
+            <a:r>
+              <a:rPr lang="es-MX" baseline="0" dirty="0" smtClean="0"/>
+              <a:t> y </a:t>
+            </a:r>
+            <a:r>
+              <a:rPr lang="es-MX" baseline="0" dirty="0" err="1" smtClean="0"/>
+              <a:t>Weinmania</a:t>
+            </a:r>
+            <a:r>
+              <a:rPr lang="es-MX" baseline="0" dirty="0" smtClean="0"/>
+              <a:t> tienen resultados que se pueden discutir. Solo en estas </a:t>
+            </a:r>
+            <a:r>
+              <a:rPr lang="es-MX" baseline="0" dirty="0" err="1" smtClean="0"/>
+              <a:t>Narea</a:t>
+            </a:r>
+            <a:r>
+              <a:rPr lang="es-MX" baseline="0" dirty="0" smtClean="0"/>
+              <a:t> funciona como predictor, pero no necesariamente en todas. </a:t>
+            </a:r>
             <a:endParaRPr lang="en-US" dirty="0"/>
           </a:p>
         </p:txBody>
@@ -930,7 +946,7 @@
     </p:spTree>
     <p:extLst>
       <p:ext uri="{BB962C8B-B14F-4D97-AF65-F5344CB8AC3E}">
-        <p14:creationId xmlns:p14="http://schemas.microsoft.com/office/powerpoint/2010/main" val="4069036078"/>
+        <p14:creationId xmlns:p14="http://schemas.microsoft.com/office/powerpoint/2010/main" val="3702535326"/>
       </p:ext>
     </p:extLst>
   </p:cSld>
@@ -984,198 +1000,6 @@
           <a:bodyPr/>
           <a:lstStyle/>
           <a:p>
-            <a:r>
-              <a:rPr lang="es-MX" dirty="0" err="1" smtClean="0"/>
-              <a:t>Exploratory</a:t>
-            </a:r>
-            <a:r>
-              <a:rPr lang="es-MX" baseline="0" dirty="0" smtClean="0"/>
-              <a:t> </a:t>
-            </a:r>
-            <a:r>
-              <a:rPr lang="es-MX" baseline="0" dirty="0" err="1" smtClean="0"/>
-              <a:t>correlations</a:t>
-            </a:r>
-            <a:r>
-              <a:rPr lang="es-MX" baseline="0" dirty="0" smtClean="0"/>
-              <a:t> </a:t>
-            </a:r>
-            <a:r>
-              <a:rPr lang="es-MX" baseline="0" dirty="0" err="1" smtClean="0"/>
-              <a:t>between</a:t>
-            </a:r>
-            <a:r>
-              <a:rPr lang="es-MX" baseline="0" dirty="0" smtClean="0"/>
-              <a:t> </a:t>
-            </a:r>
-            <a:r>
-              <a:rPr lang="es-MX" baseline="0" dirty="0" err="1" smtClean="0"/>
-              <a:t>species</a:t>
-            </a:r>
-            <a:r>
-              <a:rPr lang="es-MX" baseline="0" dirty="0" smtClean="0"/>
-              <a:t> and </a:t>
-            </a:r>
-            <a:r>
-              <a:rPr lang="es-MX" baseline="0" dirty="0" err="1" smtClean="0"/>
-              <a:t>iWUE</a:t>
-            </a:r>
-            <a:r>
-              <a:rPr lang="es-MX" baseline="0" dirty="0" smtClean="0"/>
-              <a:t>/</a:t>
-            </a:r>
-            <a:r>
-              <a:rPr lang="es-MX" baseline="0" dirty="0" err="1" smtClean="0"/>
-              <a:t>Narea</a:t>
-            </a:r>
-            <a:r>
-              <a:rPr lang="es-MX" baseline="0" dirty="0" smtClean="0"/>
-              <a:t> </a:t>
-            </a:r>
-            <a:r>
-              <a:rPr lang="es-MX" baseline="0" dirty="0" err="1" smtClean="0"/>
-              <a:t>relationship</a:t>
-            </a:r>
-            <a:r>
-              <a:rPr lang="es-MX" baseline="0" dirty="0" smtClean="0"/>
-              <a:t>. </a:t>
-            </a:r>
-            <a:r>
-              <a:rPr lang="es-MX" baseline="0" dirty="0" err="1" smtClean="0"/>
-              <a:t>Not</a:t>
-            </a:r>
-            <a:r>
-              <a:rPr lang="es-MX" baseline="0" dirty="0" smtClean="0"/>
-              <a:t> </a:t>
-            </a:r>
-            <a:r>
-              <a:rPr lang="es-MX" baseline="0" dirty="0" err="1" smtClean="0"/>
-              <a:t>always</a:t>
-            </a:r>
-            <a:r>
-              <a:rPr lang="es-MX" baseline="0" dirty="0" smtClean="0"/>
-              <a:t> </a:t>
-            </a:r>
-            <a:r>
-              <a:rPr lang="es-MX" baseline="0" dirty="0" err="1" smtClean="0"/>
-              <a:t>there</a:t>
-            </a:r>
-            <a:r>
-              <a:rPr lang="es-MX" baseline="0" dirty="0" smtClean="0"/>
-              <a:t> </a:t>
-            </a:r>
-            <a:r>
-              <a:rPr lang="es-MX" baseline="0" dirty="0" err="1" smtClean="0"/>
-              <a:t>is</a:t>
-            </a:r>
-            <a:r>
-              <a:rPr lang="es-MX" baseline="0" dirty="0" smtClean="0"/>
-              <a:t> a </a:t>
-            </a:r>
-            <a:r>
-              <a:rPr lang="es-MX" baseline="0" dirty="0" err="1" smtClean="0"/>
-              <a:t>strong</a:t>
-            </a:r>
-            <a:r>
-              <a:rPr lang="es-MX" baseline="0" dirty="0" smtClean="0"/>
-              <a:t> </a:t>
-            </a:r>
-            <a:r>
-              <a:rPr lang="es-MX" baseline="0" dirty="0" err="1" smtClean="0"/>
-              <a:t>correlation</a:t>
-            </a:r>
-            <a:r>
-              <a:rPr lang="es-MX" baseline="0" dirty="0" smtClean="0"/>
-              <a:t>. </a:t>
-            </a:r>
-            <a:r>
-              <a:rPr lang="es-MX" baseline="0" dirty="0" err="1" smtClean="0"/>
-              <a:t>Only</a:t>
-            </a:r>
-            <a:r>
-              <a:rPr lang="es-MX" baseline="0" dirty="0" smtClean="0"/>
-              <a:t> </a:t>
-            </a:r>
-            <a:r>
-              <a:rPr lang="es-MX" baseline="0" dirty="0" err="1" smtClean="0"/>
-              <a:t>significant</a:t>
-            </a:r>
-            <a:r>
-              <a:rPr lang="es-MX" baseline="0" dirty="0" smtClean="0"/>
-              <a:t> are </a:t>
-            </a:r>
-            <a:r>
-              <a:rPr lang="es-MX" baseline="0" dirty="0" err="1" smtClean="0"/>
-              <a:t>shown</a:t>
-            </a:r>
-            <a:r>
-              <a:rPr lang="es-MX" baseline="0" dirty="0" smtClean="0"/>
-              <a:t>. </a:t>
-            </a:r>
-            <a:r>
-              <a:rPr lang="es-MX" baseline="0" dirty="0" err="1" smtClean="0"/>
-              <a:t>Sometimes</a:t>
-            </a:r>
-            <a:r>
-              <a:rPr lang="es-MX" baseline="0" dirty="0" smtClean="0"/>
-              <a:t> </a:t>
-            </a:r>
-            <a:r>
-              <a:rPr lang="es-MX" baseline="0" dirty="0" err="1" smtClean="0"/>
-              <a:t>correlations</a:t>
-            </a:r>
-            <a:r>
-              <a:rPr lang="es-MX" baseline="0" dirty="0" smtClean="0"/>
-              <a:t> </a:t>
-            </a:r>
-            <a:r>
-              <a:rPr lang="es-MX" baseline="0" dirty="0" err="1" smtClean="0"/>
-              <a:t>became</a:t>
-            </a:r>
-            <a:r>
-              <a:rPr lang="es-MX" baseline="0" dirty="0" smtClean="0"/>
-              <a:t> </a:t>
-            </a:r>
-            <a:r>
-              <a:rPr lang="es-MX" baseline="0" dirty="0" err="1" smtClean="0"/>
-              <a:t>negative</a:t>
-            </a:r>
-            <a:r>
-              <a:rPr lang="es-MX" baseline="0" dirty="0" smtClean="0"/>
-              <a:t>, </a:t>
-            </a:r>
-            <a:r>
-              <a:rPr lang="es-MX" baseline="0" dirty="0" err="1" smtClean="0"/>
-              <a:t>but</a:t>
-            </a:r>
-            <a:r>
-              <a:rPr lang="es-MX" baseline="0" dirty="0" smtClean="0"/>
-              <a:t> </a:t>
-            </a:r>
-            <a:r>
-              <a:rPr lang="es-MX" baseline="0" dirty="0" err="1" smtClean="0"/>
-              <a:t>were</a:t>
-            </a:r>
-            <a:r>
-              <a:rPr lang="es-MX" baseline="0" dirty="0" smtClean="0"/>
-              <a:t> </a:t>
-            </a:r>
-            <a:r>
-              <a:rPr lang="es-MX" baseline="0" dirty="0" err="1" smtClean="0"/>
-              <a:t>not</a:t>
-            </a:r>
-            <a:r>
-              <a:rPr lang="es-MX" baseline="0" dirty="0" smtClean="0"/>
-              <a:t> </a:t>
-            </a:r>
-            <a:r>
-              <a:rPr lang="es-MX" baseline="0" dirty="0" err="1" smtClean="0"/>
-              <a:t>significant</a:t>
-            </a:r>
-            <a:r>
-              <a:rPr lang="es-MX" baseline="0" dirty="0" smtClean="0"/>
-              <a:t>. </a:t>
-            </a:r>
             <a:endParaRPr lang="en-US" dirty="0"/>
           </a:p>
         </p:txBody>
@@ -1206,7 +1030,91 @@
     </p:spTree>
     <p:extLst>
       <p:ext uri="{BB962C8B-B14F-4D97-AF65-F5344CB8AC3E}">
-        <p14:creationId xmlns:p14="http://schemas.microsoft.com/office/powerpoint/2010/main" val="1924544626"/>
+        <p14:creationId xmlns:p14="http://schemas.microsoft.com/office/powerpoint/2010/main" val="4069036078"/>
+      </p:ext>
+    </p:extLst>
+  </p:cSld>
+  <p:clrMapOvr>
+    <a:masterClrMapping/>
+  </p:clrMapOvr>
+</p:notes>
+</file>
+
+<file path=ppt/notesSlides/notesSlide5.xml><?xml version="1.0" encoding="utf-8"?>
+<p:notes xmlns:a="http://schemas.openxmlformats.org/drawingml/2006/main" xmlns:r="http://schemas.openxmlformats.org/officeDocument/2006/relationships" xmlns:p="http://schemas.openxmlformats.org/presentationml/2006/main">
+  <p:cSld>
+    <p:spTree>
+      <p:nvGrpSpPr>
+        <p:cNvPr id="1" name=""/>
+        <p:cNvGrpSpPr/>
+        <p:nvPr/>
+      </p:nvGrpSpPr>
+      <p:grpSpPr>
+        <a:xfrm>
+          <a:off x="0" y="0"/>
+          <a:ext cx="0" cy="0"/>
+          <a:chOff x="0" y="0"/>
+          <a:chExt cx="0" cy="0"/>
+        </a:xfrm>
+      </p:grpSpPr>
+      <p:sp>
+        <p:nvSpPr>
+          <p:cNvPr id="2" name="Marcador de imagen de diapositiva 1"/>
+          <p:cNvSpPr>
+            <a:spLocks noGrp="1" noRot="1" noChangeAspect="1"/>
+          </p:cNvSpPr>
+          <p:nvPr>
+            <p:ph type="sldImg"/>
+          </p:nvPr>
+        </p:nvSpPr>
+        <p:spPr/>
+      </p:sp>
+      <p:sp>
+        <p:nvSpPr>
+          <p:cNvPr id="3" name="Marcador de notas 2"/>
+          <p:cNvSpPr>
+            <a:spLocks noGrp="1"/>
+          </p:cNvSpPr>
+          <p:nvPr>
+            <p:ph type="body" idx="1"/>
+          </p:nvPr>
+        </p:nvSpPr>
+        <p:spPr/>
+        <p:txBody>
+          <a:bodyPr/>
+          <a:lstStyle/>
+          <a:p>
+            <a:endParaRPr lang="en-US" dirty="0"/>
+          </a:p>
+        </p:txBody>
+      </p:sp>
+      <p:sp>
+        <p:nvSpPr>
+          <p:cNvPr id="4" name="Marcador de número de diapositiva 3"/>
+          <p:cNvSpPr>
+            <a:spLocks noGrp="1"/>
+          </p:cNvSpPr>
+          <p:nvPr>
+            <p:ph type="sldNum" sz="quarter" idx="10"/>
+          </p:nvPr>
+        </p:nvSpPr>
+        <p:spPr/>
+        <p:txBody>
+          <a:bodyPr/>
+          <a:lstStyle/>
+          <a:p>
+            <a:fld id="{6C3F3BFB-D9DC-44A8-A360-D24B8A5210C6}" type="slidenum">
+              <a:rPr lang="en-US" smtClean="0"/>
+              <a:t>9</a:t>
+            </a:fld>
+            <a:endParaRPr lang="en-US"/>
+          </a:p>
+        </p:txBody>
+      </p:sp>
+    </p:spTree>
+    <p:extLst>
+      <p:ext uri="{BB962C8B-B14F-4D97-AF65-F5344CB8AC3E}">
+        <p14:creationId xmlns:p14="http://schemas.microsoft.com/office/powerpoint/2010/main" val="1049596090"/>
       </p:ext>
     </p:extLst>
   </p:cSld>
@@ -1347,7 +1255,7 @@
           <a:p>
             <a:fld id="{66828C04-B849-41DA-B09B-25717358C154}" type="datetimeFigureOut">
               <a:rPr lang="en-US" smtClean="0"/>
-              <a:t>3/24/2026</a:t>
+              <a:t>4/7/2026</a:t>
             </a:fld>
             <a:endParaRPr lang="en-US"/>
           </a:p>
@@ -1517,7 +1425,7 @@
           <a:p>
             <a:fld id="{66828C04-B849-41DA-B09B-25717358C154}" type="datetimeFigureOut">
               <a:rPr lang="en-US" smtClean="0"/>
-              <a:t>3/24/2026</a:t>
+              <a:t>4/7/2026</a:t>
             </a:fld>
             <a:endParaRPr lang="en-US"/>
           </a:p>
@@ -1697,7 +1605,7 @@
           <a:p>
             <a:fld id="{66828C04-B849-41DA-B09B-25717358C154}" type="datetimeFigureOut">
               <a:rPr lang="en-US" smtClean="0"/>
-              <a:t>3/24/2026</a:t>
+              <a:t>4/7/2026</a:t>
             </a:fld>
             <a:endParaRPr lang="en-US"/>
           </a:p>
@@ -1867,7 +1775,7 @@
           <a:p>
             <a:fld id="{66828C04-B849-41DA-B09B-25717358C154}" type="datetimeFigureOut">
               <a:rPr lang="en-US" smtClean="0"/>
-              <a:t>3/24/2026</a:t>
+              <a:t>4/7/2026</a:t>
             </a:fld>
             <a:endParaRPr lang="en-US"/>
           </a:p>
@@ -2113,7 +2021,7 @@
           <a:p>
             <a:fld id="{66828C04-B849-41DA-B09B-25717358C154}" type="datetimeFigureOut">
               <a:rPr lang="en-US" smtClean="0"/>
-              <a:t>3/24/2026</a:t>
+              <a:t>4/7/2026</a:t>
             </a:fld>
             <a:endParaRPr lang="en-US"/>
           </a:p>
@@ -2345,7 +2253,7 @@
           <a:p>
             <a:fld id="{66828C04-B849-41DA-B09B-25717358C154}" type="datetimeFigureOut">
               <a:rPr lang="en-US" smtClean="0"/>
-              <a:t>3/24/2026</a:t>
+              <a:t>4/7/2026</a:t>
             </a:fld>
             <a:endParaRPr lang="en-US"/>
           </a:p>
@@ -2712,7 +2620,7 @@
           <a:p>
             <a:fld id="{66828C04-B849-41DA-B09B-25717358C154}" type="datetimeFigureOut">
               <a:rPr lang="en-US" smtClean="0"/>
-              <a:t>3/24/2026</a:t>
+              <a:t>4/7/2026</a:t>
             </a:fld>
             <a:endParaRPr lang="en-US"/>
           </a:p>
@@ -2830,7 +2738,7 @@
           <a:p>
             <a:fld id="{66828C04-B849-41DA-B09B-25717358C154}" type="datetimeFigureOut">
               <a:rPr lang="en-US" smtClean="0"/>
-              <a:t>3/24/2026</a:t>
+              <a:t>4/7/2026</a:t>
             </a:fld>
             <a:endParaRPr lang="en-US"/>
           </a:p>
@@ -2925,7 +2833,7 @@
           <a:p>
             <a:fld id="{66828C04-B849-41DA-B09B-25717358C154}" type="datetimeFigureOut">
               <a:rPr lang="en-US" smtClean="0"/>
-              <a:t>3/24/2026</a:t>
+              <a:t>4/7/2026</a:t>
             </a:fld>
             <a:endParaRPr lang="en-US"/>
           </a:p>
@@ -3202,7 +3110,7 @@
           <a:p>
             <a:fld id="{66828C04-B849-41DA-B09B-25717358C154}" type="datetimeFigureOut">
               <a:rPr lang="en-US" smtClean="0"/>
-              <a:t>3/24/2026</a:t>
+              <a:t>4/7/2026</a:t>
             </a:fld>
             <a:endParaRPr lang="en-US"/>
           </a:p>
@@ -3455,7 +3363,7 @@
           <a:p>
             <a:fld id="{66828C04-B849-41DA-B09B-25717358C154}" type="datetimeFigureOut">
               <a:rPr lang="en-US" smtClean="0"/>
-              <a:t>3/24/2026</a:t>
+              <a:t>4/7/2026</a:t>
             </a:fld>
             <a:endParaRPr lang="en-US"/>
           </a:p>
@@ -3668,7 +3576,7 @@
           <a:p>
             <a:fld id="{66828C04-B849-41DA-B09B-25717358C154}" type="datetimeFigureOut">
               <a:rPr lang="en-US" smtClean="0"/>
-              <a:t>3/24/2026</a:t>
+              <a:t>4/7/2026</a:t>
             </a:fld>
             <a:endParaRPr lang="en-US"/>
           </a:p>
@@ -6255,6 +6163,13 @@
   <p:clrMapOvr>
     <a:masterClrMapping/>
   </p:clrMapOvr>
+  <p:timing>
+    <p:tnLst>
+      <p:par>
+        <p:cTn id="1" dur="indefinite" restart="never" nodeType="tmRoot"/>
+      </p:par>
+    </p:tnLst>
+  </p:timing>
 </p:sld>
 </file>
 
@@ -6359,29 +6274,6 @@
           </a:p>
         </p:txBody>
       </p:sp>
-      <p:pic>
-        <p:nvPicPr>
-          <p:cNvPr id="6" name="Imagen 5"/>
-          <p:cNvPicPr>
-            <a:picLocks noChangeAspect="1"/>
-          </p:cNvPicPr>
-          <p:nvPr/>
-        </p:nvPicPr>
-        <p:blipFill rotWithShape="1">
-          <a:blip r:embed="rId3"/>
-          <a:srcRect l="1756" t="17538" r="908" b="3770"/>
-          <a:stretch/>
-        </p:blipFill>
-        <p:spPr>
-          <a:xfrm>
-            <a:off x="443973" y="1131828"/>
-            <a:ext cx="11620648" cy="5088780"/>
-          </a:xfrm>
-          <a:prstGeom prst="rect">
-            <a:avLst/>
-          </a:prstGeom>
-        </p:spPr>
-      </p:pic>
       <p:sp>
         <p:nvSpPr>
           <p:cNvPr id="8" name="CuadroTexto 7"/>
@@ -6390,8 +6282,8 @@
         </p:nvSpPr>
         <p:spPr>
           <a:xfrm rot="16200000">
-            <a:off x="-3743168" y="1790581"/>
-            <a:ext cx="7727950" cy="646331"/>
+            <a:off x="-3924304" y="2024542"/>
+            <a:ext cx="8098022" cy="584775"/>
           </a:xfrm>
           <a:prstGeom prst="rect">
             <a:avLst/>
@@ -6408,54 +6300,90 @@
           </a:p>
           <a:p>
             <a:r>
-              <a:rPr lang="en-US" b="1" dirty="0" smtClean="0"/>
-              <a:t>SLA (g/m2)            </a:t>
-            </a:r>
-            <a:r>
-              <a:rPr lang="en-US" b="1" dirty="0" err="1" smtClean="0"/>
+              <a:rPr lang="en-US" sz="1400" b="1" dirty="0" smtClean="0"/>
+              <a:t>SLA (g/m2</a:t>
+            </a:r>
+            <a:r>
+              <a:rPr lang="en-US" sz="1400" b="1" dirty="0" smtClean="0"/>
+              <a:t>)              </a:t>
+            </a:r>
+            <a:r>
+              <a:rPr lang="en-US" sz="1400" b="1" dirty="0" err="1" smtClean="0"/>
+              <a:t>P</a:t>
+            </a:r>
+            <a:r>
+              <a:rPr lang="en-US" sz="1400" b="1" dirty="0" err="1" smtClean="0"/>
+              <a:t>area</a:t>
+            </a:r>
+            <a:r>
+              <a:rPr lang="en-US" sz="1400" b="1" dirty="0" smtClean="0"/>
+              <a:t>(g/m</a:t>
+            </a:r>
+            <a:r>
+              <a:rPr lang="en-US" sz="1400" b="1" baseline="30000" dirty="0" smtClean="0"/>
+              <a:t>2</a:t>
+            </a:r>
+            <a:r>
+              <a:rPr lang="en-US" sz="1400" b="1" dirty="0" smtClean="0"/>
+              <a:t> </a:t>
+            </a:r>
+            <a:r>
+              <a:rPr lang="en-US" sz="1400" b="1" dirty="0"/>
+              <a:t>)   </a:t>
+            </a:r>
+            <a:r>
+              <a:rPr lang="en-US" sz="1400" b="1" dirty="0" smtClean="0"/>
+              <a:t>               </a:t>
+            </a:r>
+            <a:r>
+              <a:rPr lang="en-US" sz="1400" b="1" dirty="0" err="1" smtClean="0"/>
               <a:t>Narea</a:t>
             </a:r>
             <a:r>
-              <a:rPr lang="en-US" b="1" dirty="0" smtClean="0"/>
+              <a:rPr lang="en-US" sz="1400" b="1" dirty="0" smtClean="0"/>
               <a:t>(g/m</a:t>
             </a:r>
             <a:r>
-              <a:rPr lang="en-US" b="1" baseline="30000" dirty="0" smtClean="0"/>
+              <a:rPr lang="en-US" sz="1400" b="1" baseline="30000" dirty="0" smtClean="0"/>
               <a:t>2</a:t>
             </a:r>
             <a:r>
-              <a:rPr lang="en-US" b="1" dirty="0" smtClean="0"/>
-              <a:t> )         </a:t>
-            </a:r>
-            <a:r>
-              <a:rPr lang="en-US" b="1" dirty="0" err="1" smtClean="0"/>
+              <a:rPr lang="en-US" sz="1400" b="1" dirty="0" smtClean="0"/>
+              <a:t> )      </a:t>
+            </a:r>
+            <a:r>
+              <a:rPr lang="en-US" sz="1400" b="1" dirty="0" smtClean="0"/>
+              <a:t>    </a:t>
+            </a:r>
+            <a:r>
+              <a:rPr lang="en-US" sz="1400" b="1" dirty="0" err="1" smtClean="0"/>
               <a:t>iWUE</a:t>
             </a:r>
             <a:r>
-              <a:rPr lang="en-US" b="1" dirty="0" smtClean="0"/>
+              <a:rPr lang="en-US" sz="1400" b="1" dirty="0" smtClean="0"/>
               <a:t> (</a:t>
             </a:r>
             <a:r>
-              <a:rPr lang="el-GR" b="1" dirty="0" smtClean="0"/>
+              <a:rPr lang="el-GR" sz="1400" b="1" dirty="0" smtClean="0"/>
               <a:t>μ</a:t>
             </a:r>
             <a:r>
-              <a:rPr lang="en-US" b="1" dirty="0" err="1" smtClean="0"/>
+              <a:rPr lang="en-US" sz="1400" b="1" dirty="0" err="1" smtClean="0"/>
               <a:t>mol</a:t>
             </a:r>
             <a:r>
-              <a:rPr lang="en-US" b="1" dirty="0" smtClean="0"/>
+              <a:rPr lang="en-US" sz="1400" b="1" dirty="0" smtClean="0"/>
               <a:t>/</a:t>
             </a:r>
             <a:r>
-              <a:rPr lang="en-US" b="1" dirty="0" err="1" smtClean="0"/>
+              <a:rPr lang="en-US" sz="1400" b="1" dirty="0" err="1" smtClean="0"/>
               <a:t>mol</a:t>
             </a:r>
             <a:r>
-              <a:rPr lang="en-US" b="1" dirty="0" smtClean="0"/>
+              <a:rPr lang="en-US" sz="1400" b="1" dirty="0" smtClean="0"/>
               <a:t>)</a:t>
             </a:r>
-            <a:endParaRPr lang="en-US" b="1" dirty="0"/>
+            <a:endParaRPr lang="en-US" sz="1400" b="1" dirty="0"/>
           </a:p>
         </p:txBody>
       </p:sp>
@@ -6467,7 +6395,7 @@
         </p:nvSpPr>
         <p:spPr>
           <a:xfrm>
-            <a:off x="451217" y="773395"/>
+            <a:off x="430238" y="134270"/>
             <a:ext cx="3810000" cy="358433"/>
           </a:xfrm>
           <a:prstGeom prst="rect">
@@ -6511,7 +6439,7 @@
         </p:nvSpPr>
         <p:spPr>
           <a:xfrm>
-            <a:off x="443972" y="773395"/>
+            <a:off x="428469" y="114231"/>
             <a:ext cx="3814129" cy="5403568"/>
           </a:xfrm>
           <a:prstGeom prst="rect">
@@ -6649,7 +6577,7 @@
         </p:nvSpPr>
         <p:spPr>
           <a:xfrm>
-            <a:off x="4261217" y="773395"/>
+            <a:off x="4261217" y="115005"/>
             <a:ext cx="3810000" cy="358433"/>
           </a:xfrm>
           <a:prstGeom prst="rect">
@@ -6697,7 +6625,7 @@
         </p:nvSpPr>
         <p:spPr>
           <a:xfrm>
-            <a:off x="8068100" y="795217"/>
+            <a:off x="8068101" y="115005"/>
             <a:ext cx="3810000" cy="358433"/>
           </a:xfrm>
           <a:prstGeom prst="rect">
@@ -6737,6 +6665,29 @@
           </a:p>
         </p:txBody>
       </p:sp>
+      <p:pic>
+        <p:nvPicPr>
+          <p:cNvPr id="4" name="Imagen 3"/>
+          <p:cNvPicPr>
+            <a:picLocks noChangeAspect="1"/>
+          </p:cNvPicPr>
+          <p:nvPr/>
+        </p:nvPicPr>
+        <p:blipFill rotWithShape="1">
+          <a:blip r:embed="rId3"/>
+          <a:srcRect l="1254" t="4675" r="416" b="2362"/>
+          <a:stretch/>
+        </p:blipFill>
+        <p:spPr>
+          <a:xfrm>
+            <a:off x="406945" y="512742"/>
+            <a:ext cx="11657675" cy="5969945"/>
+          </a:xfrm>
+          <a:prstGeom prst="rect">
+            <a:avLst/>
+          </a:prstGeom>
+        </p:spPr>
+      </p:pic>
     </p:spTree>
     <p:extLst>
       <p:ext uri="{BB962C8B-B14F-4D97-AF65-F5344CB8AC3E}">
@@ -6747,10 +6698,552 @@
   <p:clrMapOvr>
     <a:masterClrMapping/>
   </p:clrMapOvr>
+  <p:timing>
+    <p:tnLst>
+      <p:par>
+        <p:cTn id="1" dur="indefinite" restart="never" nodeType="tmRoot"/>
+      </p:par>
+    </p:tnLst>
+  </p:timing>
 </p:sld>
 </file>
 
 <file path=ppt/slides/slide6.xml><?xml version="1.0" encoding="utf-8"?>
+<p:sld xmlns:a="http://schemas.openxmlformats.org/drawingml/2006/main" xmlns:r="http://schemas.openxmlformats.org/officeDocument/2006/relationships" xmlns:p="http://schemas.openxmlformats.org/presentationml/2006/main">
+  <p:cSld>
+    <p:spTree>
+      <p:nvGrpSpPr>
+        <p:cNvPr id="1" name=""/>
+        <p:cNvGrpSpPr/>
+        <p:nvPr/>
+      </p:nvGrpSpPr>
+      <p:grpSpPr>
+        <a:xfrm>
+          <a:off x="0" y="0"/>
+          <a:ext cx="0" cy="0"/>
+          <a:chOff x="0" y="0"/>
+          <a:chExt cx="0" cy="0"/>
+        </a:xfrm>
+      </p:grpSpPr>
+      <p:sp>
+        <p:nvSpPr>
+          <p:cNvPr id="7" name="Rectángulo 6"/>
+          <p:cNvSpPr/>
+          <p:nvPr/>
+        </p:nvSpPr>
+        <p:spPr>
+          <a:xfrm>
+            <a:off x="122829" y="203981"/>
+            <a:ext cx="11941791" cy="6278706"/>
+          </a:xfrm>
+          <a:prstGeom prst="rect">
+            <a:avLst/>
+          </a:prstGeom>
+          <a:solidFill>
+            <a:schemeClr val="bg2"/>
+          </a:solidFill>
+          <a:ln>
+            <a:noFill/>
+          </a:ln>
+        </p:spPr>
+        <p:style>
+          <a:lnRef idx="2">
+            <a:schemeClr val="accent1">
+              <a:shade val="50000"/>
+            </a:schemeClr>
+          </a:lnRef>
+          <a:fillRef idx="1">
+            <a:schemeClr val="accent1"/>
+          </a:fillRef>
+          <a:effectRef idx="0">
+            <a:schemeClr val="accent1"/>
+          </a:effectRef>
+          <a:fontRef idx="minor">
+            <a:schemeClr val="lt1"/>
+          </a:fontRef>
+        </p:style>
+        <p:txBody>
+          <a:bodyPr rtlCol="0" anchor="ctr"/>
+          <a:lstStyle/>
+          <a:p>
+            <a:pPr algn="ctr"/>
+            <a:endParaRPr lang="en-US"/>
+          </a:p>
+        </p:txBody>
+      </p:sp>
+      <p:sp>
+        <p:nvSpPr>
+          <p:cNvPr id="2" name="Título 1"/>
+          <p:cNvSpPr>
+            <a:spLocks noGrp="1"/>
+          </p:cNvSpPr>
+          <p:nvPr>
+            <p:ph type="title"/>
+          </p:nvPr>
+        </p:nvSpPr>
+        <p:spPr/>
+        <p:txBody>
+          <a:bodyPr/>
+          <a:lstStyle/>
+          <a:p>
+            <a:endParaRPr lang="en-US" dirty="0"/>
+          </a:p>
+        </p:txBody>
+      </p:sp>
+      <p:sp>
+        <p:nvSpPr>
+          <p:cNvPr id="3" name="Marcador de contenido 2"/>
+          <p:cNvSpPr>
+            <a:spLocks noGrp="1"/>
+          </p:cNvSpPr>
+          <p:nvPr>
+            <p:ph idx="1"/>
+          </p:nvPr>
+        </p:nvSpPr>
+        <p:spPr/>
+        <p:txBody>
+          <a:bodyPr/>
+          <a:lstStyle/>
+          <a:p>
+            <a:endParaRPr lang="en-US"/>
+          </a:p>
+        </p:txBody>
+      </p:sp>
+      <p:sp>
+        <p:nvSpPr>
+          <p:cNvPr id="8" name="CuadroTexto 7"/>
+          <p:cNvSpPr txBox="1"/>
+          <p:nvPr/>
+        </p:nvSpPr>
+        <p:spPr>
+          <a:xfrm rot="16200000">
+            <a:off x="-3924304" y="2024542"/>
+            <a:ext cx="8098022" cy="584775"/>
+          </a:xfrm>
+          <a:prstGeom prst="rect">
+            <a:avLst/>
+          </a:prstGeom>
+          <a:noFill/>
+        </p:spPr>
+        <p:txBody>
+          <a:bodyPr wrap="square" rtlCol="0">
+            <a:spAutoFit/>
+          </a:bodyPr>
+          <a:lstStyle/>
+          <a:p>
+            <a:endParaRPr lang="en-US" b="1" dirty="0" smtClean="0"/>
+          </a:p>
+          <a:p>
+            <a:r>
+              <a:rPr lang="en-US" sz="1400" b="1" dirty="0" smtClean="0"/>
+              <a:t>SLA (g/m2</a:t>
+            </a:r>
+            <a:r>
+              <a:rPr lang="en-US" sz="1400" b="1" dirty="0" smtClean="0"/>
+              <a:t>)              </a:t>
+            </a:r>
+            <a:r>
+              <a:rPr lang="en-US" sz="1400" b="1" dirty="0" err="1" smtClean="0"/>
+              <a:t>P</a:t>
+            </a:r>
+            <a:r>
+              <a:rPr lang="en-US" sz="1400" b="1" dirty="0" err="1" smtClean="0"/>
+              <a:t>area</a:t>
+            </a:r>
+            <a:r>
+              <a:rPr lang="en-US" sz="1400" b="1" dirty="0" smtClean="0"/>
+              <a:t>(g/m</a:t>
+            </a:r>
+            <a:r>
+              <a:rPr lang="en-US" sz="1400" b="1" baseline="30000" dirty="0" smtClean="0"/>
+              <a:t>2</a:t>
+            </a:r>
+            <a:r>
+              <a:rPr lang="en-US" sz="1400" b="1" dirty="0" smtClean="0"/>
+              <a:t> </a:t>
+            </a:r>
+            <a:r>
+              <a:rPr lang="en-US" sz="1400" b="1" dirty="0"/>
+              <a:t>)   </a:t>
+            </a:r>
+            <a:r>
+              <a:rPr lang="en-US" sz="1400" b="1" dirty="0" smtClean="0"/>
+              <a:t>               </a:t>
+            </a:r>
+            <a:r>
+              <a:rPr lang="en-US" sz="1400" b="1" dirty="0" err="1" smtClean="0"/>
+              <a:t>Narea</a:t>
+            </a:r>
+            <a:r>
+              <a:rPr lang="en-US" sz="1400" b="1" dirty="0" smtClean="0"/>
+              <a:t>(g/m</a:t>
+            </a:r>
+            <a:r>
+              <a:rPr lang="en-US" sz="1400" b="1" baseline="30000" dirty="0" smtClean="0"/>
+              <a:t>2</a:t>
+            </a:r>
+            <a:r>
+              <a:rPr lang="en-US" sz="1400" b="1" dirty="0" smtClean="0"/>
+              <a:t> )      </a:t>
+            </a:r>
+            <a:r>
+              <a:rPr lang="en-US" sz="1400" b="1" dirty="0" smtClean="0"/>
+              <a:t>    </a:t>
+            </a:r>
+            <a:r>
+              <a:rPr lang="en-US" sz="1400" b="1" dirty="0" err="1" smtClean="0"/>
+              <a:t>iWUE</a:t>
+            </a:r>
+            <a:r>
+              <a:rPr lang="en-US" sz="1400" b="1" dirty="0" smtClean="0"/>
+              <a:t> (</a:t>
+            </a:r>
+            <a:r>
+              <a:rPr lang="el-GR" sz="1400" b="1" dirty="0" smtClean="0"/>
+              <a:t>μ</a:t>
+            </a:r>
+            <a:r>
+              <a:rPr lang="en-US" sz="1400" b="1" dirty="0" err="1" smtClean="0"/>
+              <a:t>mol</a:t>
+            </a:r>
+            <a:r>
+              <a:rPr lang="en-US" sz="1400" b="1" dirty="0" smtClean="0"/>
+              <a:t>/</a:t>
+            </a:r>
+            <a:r>
+              <a:rPr lang="en-US" sz="1400" b="1" dirty="0" err="1" smtClean="0"/>
+              <a:t>mol</a:t>
+            </a:r>
+            <a:r>
+              <a:rPr lang="en-US" sz="1400" b="1" dirty="0" smtClean="0"/>
+              <a:t>)</a:t>
+            </a:r>
+            <a:endParaRPr lang="en-US" sz="1400" b="1" dirty="0"/>
+          </a:p>
+        </p:txBody>
+      </p:sp>
+      <p:sp>
+        <p:nvSpPr>
+          <p:cNvPr id="9" name="Rectángulo 8"/>
+          <p:cNvSpPr/>
+          <p:nvPr/>
+        </p:nvSpPr>
+        <p:spPr>
+          <a:xfrm>
+            <a:off x="430238" y="134270"/>
+            <a:ext cx="3810000" cy="358433"/>
+          </a:xfrm>
+          <a:prstGeom prst="rect">
+            <a:avLst/>
+          </a:prstGeom>
+        </p:spPr>
+        <p:style>
+          <a:lnRef idx="2">
+            <a:schemeClr val="accent3">
+              <a:shade val="50000"/>
+            </a:schemeClr>
+          </a:lnRef>
+          <a:fillRef idx="1">
+            <a:schemeClr val="accent3"/>
+          </a:fillRef>
+          <a:effectRef idx="0">
+            <a:schemeClr val="accent3"/>
+          </a:effectRef>
+          <a:fontRef idx="minor">
+            <a:schemeClr val="lt1"/>
+          </a:fontRef>
+        </p:style>
+        <p:txBody>
+          <a:bodyPr rtlCol="0" anchor="ctr"/>
+          <a:lstStyle/>
+          <a:p>
+            <a:pPr algn="ctr"/>
+            <a:r>
+              <a:rPr lang="es-MX" dirty="0" smtClean="0"/>
+              <a:t>1000 m</a:t>
+            </a:r>
+            <a:endParaRPr lang="en-US" dirty="0"/>
+          </a:p>
+        </p:txBody>
+      </p:sp>
+      <p:sp>
+        <p:nvSpPr>
+          <p:cNvPr id="12" name="Rectángulo 11"/>
+          <p:cNvSpPr/>
+          <p:nvPr/>
+        </p:nvSpPr>
+        <p:spPr>
+          <a:xfrm>
+            <a:off x="428469" y="114231"/>
+            <a:ext cx="3814129" cy="5403568"/>
+          </a:xfrm>
+          <a:prstGeom prst="rect">
+            <a:avLst/>
+          </a:prstGeom>
+          <a:noFill/>
+          <a:ln>
+            <a:solidFill>
+              <a:schemeClr val="tx1"/>
+            </a:solidFill>
+          </a:ln>
+        </p:spPr>
+        <p:style>
+          <a:lnRef idx="2">
+            <a:schemeClr val="accent1">
+              <a:shade val="50000"/>
+            </a:schemeClr>
+          </a:lnRef>
+          <a:fillRef idx="1">
+            <a:schemeClr val="accent1"/>
+          </a:fillRef>
+          <a:effectRef idx="0">
+            <a:schemeClr val="accent1"/>
+          </a:effectRef>
+          <a:fontRef idx="minor">
+            <a:schemeClr val="lt1"/>
+          </a:fontRef>
+        </p:style>
+        <p:txBody>
+          <a:bodyPr rtlCol="0" anchor="ctr"/>
+          <a:lstStyle/>
+          <a:p>
+            <a:pPr algn="ctr"/>
+            <a:endParaRPr lang="en-US"/>
+          </a:p>
+        </p:txBody>
+      </p:sp>
+      <p:sp>
+        <p:nvSpPr>
+          <p:cNvPr id="14" name="Rectángulo 13"/>
+          <p:cNvSpPr/>
+          <p:nvPr/>
+        </p:nvSpPr>
+        <p:spPr>
+          <a:xfrm>
+            <a:off x="4253972" y="791567"/>
+            <a:ext cx="3814129" cy="5403568"/>
+          </a:xfrm>
+          <a:prstGeom prst="rect">
+            <a:avLst/>
+          </a:prstGeom>
+          <a:noFill/>
+          <a:ln>
+            <a:solidFill>
+              <a:schemeClr val="tx1"/>
+            </a:solidFill>
+          </a:ln>
+        </p:spPr>
+        <p:style>
+          <a:lnRef idx="2">
+            <a:schemeClr val="accent1">
+              <a:shade val="50000"/>
+            </a:schemeClr>
+          </a:lnRef>
+          <a:fillRef idx="1">
+            <a:schemeClr val="accent1"/>
+          </a:fillRef>
+          <a:effectRef idx="0">
+            <a:schemeClr val="accent1"/>
+          </a:effectRef>
+          <a:fontRef idx="minor">
+            <a:schemeClr val="lt1"/>
+          </a:fontRef>
+        </p:style>
+        <p:txBody>
+          <a:bodyPr rtlCol="0" anchor="ctr"/>
+          <a:lstStyle/>
+          <a:p>
+            <a:pPr algn="ctr"/>
+            <a:endParaRPr lang="en-US"/>
+          </a:p>
+        </p:txBody>
+      </p:sp>
+      <p:sp>
+        <p:nvSpPr>
+          <p:cNvPr id="15" name="Rectángulo 14"/>
+          <p:cNvSpPr/>
+          <p:nvPr/>
+        </p:nvSpPr>
+        <p:spPr>
+          <a:xfrm>
+            <a:off x="8075345" y="790905"/>
+            <a:ext cx="3814129" cy="5403568"/>
+          </a:xfrm>
+          <a:prstGeom prst="rect">
+            <a:avLst/>
+          </a:prstGeom>
+          <a:noFill/>
+          <a:ln>
+            <a:solidFill>
+              <a:schemeClr val="tx1"/>
+            </a:solidFill>
+          </a:ln>
+        </p:spPr>
+        <p:style>
+          <a:lnRef idx="2">
+            <a:schemeClr val="accent1">
+              <a:shade val="50000"/>
+            </a:schemeClr>
+          </a:lnRef>
+          <a:fillRef idx="1">
+            <a:schemeClr val="accent1"/>
+          </a:fillRef>
+          <a:effectRef idx="0">
+            <a:schemeClr val="accent1"/>
+          </a:effectRef>
+          <a:fontRef idx="minor">
+            <a:schemeClr val="lt1"/>
+          </a:fontRef>
+        </p:style>
+        <p:txBody>
+          <a:bodyPr rtlCol="0" anchor="ctr"/>
+          <a:lstStyle/>
+          <a:p>
+            <a:pPr algn="ctr"/>
+            <a:endParaRPr lang="en-US"/>
+          </a:p>
+        </p:txBody>
+      </p:sp>
+      <p:sp>
+        <p:nvSpPr>
+          <p:cNvPr id="16" name="Rectángulo 15"/>
+          <p:cNvSpPr/>
+          <p:nvPr/>
+        </p:nvSpPr>
+        <p:spPr>
+          <a:xfrm>
+            <a:off x="4261217" y="115005"/>
+            <a:ext cx="3810000" cy="358433"/>
+          </a:xfrm>
+          <a:prstGeom prst="rect">
+            <a:avLst/>
+          </a:prstGeom>
+        </p:spPr>
+        <p:style>
+          <a:lnRef idx="2">
+            <a:schemeClr val="accent3">
+              <a:shade val="50000"/>
+            </a:schemeClr>
+          </a:lnRef>
+          <a:fillRef idx="1">
+            <a:schemeClr val="accent3"/>
+          </a:fillRef>
+          <a:effectRef idx="0">
+            <a:schemeClr val="accent3"/>
+          </a:effectRef>
+          <a:fontRef idx="minor">
+            <a:schemeClr val="lt1"/>
+          </a:fontRef>
+        </p:style>
+        <p:txBody>
+          <a:bodyPr rtlCol="0" anchor="ctr"/>
+          <a:lstStyle/>
+          <a:p>
+            <a:pPr algn="ctr"/>
+            <a:r>
+              <a:rPr lang="es-MX" dirty="0"/>
+              <a:t>2</a:t>
+            </a:r>
+            <a:r>
+              <a:rPr lang="es-MX" dirty="0" smtClean="0"/>
+              <a:t>000 m</a:t>
+            </a:r>
+            <a:endParaRPr lang="en-US" dirty="0"/>
+          </a:p>
+        </p:txBody>
+      </p:sp>
+      <p:sp>
+        <p:nvSpPr>
+          <p:cNvPr id="18" name="Rectángulo 17"/>
+          <p:cNvSpPr/>
+          <p:nvPr/>
+        </p:nvSpPr>
+        <p:spPr>
+          <a:xfrm>
+            <a:off x="8068101" y="115005"/>
+            <a:ext cx="3810000" cy="358433"/>
+          </a:xfrm>
+          <a:prstGeom prst="rect">
+            <a:avLst/>
+          </a:prstGeom>
+        </p:spPr>
+        <p:style>
+          <a:lnRef idx="2">
+            <a:schemeClr val="accent3">
+              <a:shade val="50000"/>
+            </a:schemeClr>
+          </a:lnRef>
+          <a:fillRef idx="1">
+            <a:schemeClr val="accent3"/>
+          </a:fillRef>
+          <a:effectRef idx="0">
+            <a:schemeClr val="accent3"/>
+          </a:effectRef>
+          <a:fontRef idx="minor">
+            <a:schemeClr val="lt1"/>
+          </a:fontRef>
+        </p:style>
+        <p:txBody>
+          <a:bodyPr rtlCol="0" anchor="ctr"/>
+          <a:lstStyle/>
+          <a:p>
+            <a:pPr algn="ctr"/>
+            <a:r>
+              <a:rPr lang="es-MX" dirty="0"/>
+              <a:t>3</a:t>
+            </a:r>
+            <a:r>
+              <a:rPr lang="es-MX" dirty="0" smtClean="0"/>
+              <a:t>000 m</a:t>
+            </a:r>
+            <a:endParaRPr lang="en-US" dirty="0"/>
+          </a:p>
+        </p:txBody>
+      </p:sp>
+      <p:pic>
+        <p:nvPicPr>
+          <p:cNvPr id="13" name="Imagen 12"/>
+          <p:cNvPicPr>
+            <a:picLocks noChangeAspect="1"/>
+          </p:cNvPicPr>
+          <p:nvPr/>
+        </p:nvPicPr>
+        <p:blipFill rotWithShape="1">
+          <a:blip r:embed="rId3"/>
+          <a:srcRect l="798" t="3932" r="897" b="2325"/>
+          <a:stretch/>
+        </p:blipFill>
+        <p:spPr>
+          <a:xfrm>
+            <a:off x="417095" y="479452"/>
+            <a:ext cx="11622157" cy="6003235"/>
+          </a:xfrm>
+          <a:prstGeom prst="rect">
+            <a:avLst/>
+          </a:prstGeom>
+        </p:spPr>
+      </p:pic>
+    </p:spTree>
+    <p:extLst>
+      <p:ext uri="{BB962C8B-B14F-4D97-AF65-F5344CB8AC3E}">
+        <p14:creationId xmlns:p14="http://schemas.microsoft.com/office/powerpoint/2010/main" val="2820552992"/>
+      </p:ext>
+    </p:extLst>
+  </p:cSld>
+  <p:clrMapOvr>
+    <a:masterClrMapping/>
+  </p:clrMapOvr>
+  <p:timing>
+    <p:tnLst>
+      <p:par>
+        <p:cTn id="1" dur="indefinite" restart="never" nodeType="tmRoot"/>
+      </p:par>
+    </p:tnLst>
+  </p:timing>
+</p:sld>
+</file>
+
+<file path=ppt/slides/slide7.xml><?xml version="1.0" encoding="utf-8"?>
 <p:sld xmlns:a="http://schemas.openxmlformats.org/drawingml/2006/main" xmlns:r="http://schemas.openxmlformats.org/officeDocument/2006/relationships" xmlns:p="http://schemas.openxmlformats.org/presentationml/2006/main">
   <p:cSld>
     <p:spTree>
@@ -6877,10 +7370,17 @@
   <p:clrMapOvr>
     <a:masterClrMapping/>
   </p:clrMapOvr>
+  <p:timing>
+    <p:tnLst>
+      <p:par>
+        <p:cTn id="1" dur="indefinite" restart="never" nodeType="tmRoot"/>
+      </p:par>
+    </p:tnLst>
+  </p:timing>
 </p:sld>
 </file>
 
-<file path=ppt/slides/slide7.xml><?xml version="1.0" encoding="utf-8"?>
+<file path=ppt/slides/slide8.xml><?xml version="1.0" encoding="utf-8"?>
 <p:sld xmlns:a="http://schemas.openxmlformats.org/drawingml/2006/main" xmlns:r="http://schemas.openxmlformats.org/officeDocument/2006/relationships" xmlns:p="http://schemas.openxmlformats.org/presentationml/2006/main">
   <p:cSld>
     <p:spTree>
@@ -6935,67 +7435,6 @@
           </a:p>
         </p:txBody>
       </p:sp>
-      <p:pic>
-        <p:nvPicPr>
-          <p:cNvPr id="4" name="Imagen 3"/>
-          <p:cNvPicPr>
-            <a:picLocks noChangeAspect="1"/>
-          </p:cNvPicPr>
-          <p:nvPr/>
-        </p:nvPicPr>
-        <p:blipFill rotWithShape="1">
-          <a:blip r:embed="rId3"/>
-          <a:srcRect l="1478" t="17799" r="1774" b="1852"/>
-          <a:stretch/>
-        </p:blipFill>
-        <p:spPr>
-          <a:xfrm>
-            <a:off x="246196" y="944007"/>
-            <a:ext cx="12325025" cy="5544465"/>
-          </a:xfrm>
-          <a:prstGeom prst="rect">
-            <a:avLst/>
-          </a:prstGeom>
-        </p:spPr>
-      </p:pic>
-      <p:sp>
-        <p:nvSpPr>
-          <p:cNvPr id="5" name="CuadroTexto 4"/>
-          <p:cNvSpPr txBox="1"/>
-          <p:nvPr/>
-        </p:nvSpPr>
-        <p:spPr>
-          <a:xfrm>
-            <a:off x="838200" y="5115678"/>
-            <a:ext cx="10323647" cy="707886"/>
-          </a:xfrm>
-          <a:prstGeom prst="rect">
-            <a:avLst/>
-          </a:prstGeom>
-          <a:noFill/>
-        </p:spPr>
-        <p:txBody>
-          <a:bodyPr wrap="square" rtlCol="0">
-            <a:spAutoFit/>
-          </a:bodyPr>
-          <a:lstStyle/>
-          <a:p>
-            <a:r>
-              <a:rPr lang="es-MX" sz="4000" b="1" dirty="0" smtClean="0">
-                <a:solidFill>
-                  <a:srgbClr val="FF0000"/>
-                </a:solidFill>
-              </a:rPr>
-              <a:t>REVISANDO TODAVIA</a:t>
-            </a:r>
-            <a:endParaRPr lang="en-US" sz="4000" b="1" dirty="0">
-              <a:solidFill>
-                <a:srgbClr val="FF0000"/>
-              </a:solidFill>
-            </a:endParaRPr>
-          </a:p>
-        </p:txBody>
-      </p:sp>
     </p:spTree>
     <p:extLst>
       <p:ext uri="{BB962C8B-B14F-4D97-AF65-F5344CB8AC3E}">
@@ -7006,11 +7445,18 @@
   <p:clrMapOvr>
     <a:masterClrMapping/>
   </p:clrMapOvr>
+  <p:timing>
+    <p:tnLst>
+      <p:par>
+        <p:cTn id="1" dur="indefinite" restart="never" nodeType="tmRoot"/>
+      </p:par>
+    </p:tnLst>
+  </p:timing>
 </p:sld>
 </file>
 
-<file path=ppt/slides/slide8.xml><?xml version="1.0" encoding="utf-8"?>
-<p:sld xmlns:a="http://schemas.openxmlformats.org/drawingml/2006/main" xmlns:r="http://schemas.openxmlformats.org/officeDocument/2006/relationships" xmlns:p="http://schemas.openxmlformats.org/presentationml/2006/main" show="0">
+<file path=ppt/slides/slide9.xml><?xml version="1.0" encoding="utf-8"?>
+<p:sld xmlns:a="http://schemas.openxmlformats.org/drawingml/2006/main" xmlns:r="http://schemas.openxmlformats.org/officeDocument/2006/relationships" xmlns:p="http://schemas.openxmlformats.org/presentationml/2006/main">
   <p:cSld>
     <p:spTree>
       <p:nvGrpSpPr>
@@ -7041,73 +7487,29 @@
           <a:bodyPr/>
           <a:lstStyle/>
           <a:p>
-            <a:endParaRPr lang="en-US"/>
-          </a:p>
-        </p:txBody>
-      </p:sp>
-      <p:sp>
-        <p:nvSpPr>
-          <p:cNvPr id="6" name="AutoShape 2" descr="http://127.0.0.1:45656/chunk_output/s/ADA79C0F/cavyufzpe0cze/00001d.png"/>
-          <p:cNvSpPr>
-            <a:spLocks noChangeAspect="1" noChangeArrowheads="1"/>
-          </p:cNvSpPr>
-          <p:nvPr/>
-        </p:nvSpPr>
-        <p:spPr bwMode="auto">
-          <a:xfrm>
-            <a:off x="63500" y="-136525"/>
-            <a:ext cx="304800" cy="304800"/>
-          </a:xfrm>
-          <a:prstGeom prst="rect">
-            <a:avLst/>
-          </a:prstGeom>
-          <a:noFill/>
-          <a:extLst>
-            <a:ext uri="{909E8E84-426E-40DD-AFC4-6F175D3DCCD1}">
-              <a14:hiddenFill xmlns:a14="http://schemas.microsoft.com/office/drawing/2010/main">
-                <a:solidFill>
-                  <a:srgbClr val="FFFFFF"/>
-                </a:solidFill>
-              </a14:hiddenFill>
-            </a:ext>
-          </a:extLst>
-        </p:spPr>
-        <p:txBody>
-          <a:bodyPr vert="horz" wrap="square" lIns="91440" tIns="45720" rIns="91440" bIns="45720" numCol="1" anchor="t" anchorCtr="0" compatLnSpc="1">
-            <a:prstTxWarp prst="textNoShape">
-              <a:avLst/>
-            </a:prstTxWarp>
-          </a:bodyPr>
-          <a:lstStyle/>
-          <a:p>
-            <a:endParaRPr lang="en-US"/>
-          </a:p>
-        </p:txBody>
-      </p:sp>
-      <p:pic>
-        <p:nvPicPr>
-          <p:cNvPr id="10" name="Imagen 9"/>
-          <p:cNvPicPr>
-            <a:picLocks noChangeAspect="1"/>
-          </p:cNvPicPr>
-          <p:nvPr/>
-        </p:nvPicPr>
-        <p:blipFill>
-          <a:blip r:embed="rId3"/>
-          <a:stretch>
-            <a:fillRect/>
-          </a:stretch>
-        </p:blipFill>
-        <p:spPr>
-          <a:xfrm>
-            <a:off x="545392" y="168275"/>
-            <a:ext cx="11101216" cy="6189393"/>
-          </a:xfrm>
-          <a:prstGeom prst="rect">
-            <a:avLst/>
-          </a:prstGeom>
-        </p:spPr>
-      </p:pic>
+            <a:endParaRPr lang="en-US" dirty="0"/>
+          </a:p>
+        </p:txBody>
+      </p:sp>
+      <p:sp>
+        <p:nvSpPr>
+          <p:cNvPr id="3" name="Marcador de contenido 2"/>
+          <p:cNvSpPr>
+            <a:spLocks noGrp="1"/>
+          </p:cNvSpPr>
+          <p:nvPr>
+            <p:ph idx="1"/>
+          </p:nvPr>
+        </p:nvSpPr>
+        <p:spPr/>
+        <p:txBody>
+          <a:bodyPr/>
+          <a:lstStyle/>
+          <a:p>
+            <a:endParaRPr lang="en-US"/>
+          </a:p>
+        </p:txBody>
+      </p:sp>
       <p:sp>
         <p:nvSpPr>
           <p:cNvPr id="5" name="CuadroTexto 4"/>
@@ -7116,7 +7518,7 @@
         </p:nvSpPr>
         <p:spPr>
           <a:xfrm>
-            <a:off x="838200" y="5115678"/>
+            <a:off x="349102" y="5957957"/>
             <a:ext cx="10323647" cy="707886"/>
           </a:xfrm>
           <a:prstGeom prst="rect">
@@ -7143,82 +7545,6 @@
                 <a:srgbClr val="FF0000"/>
               </a:solidFill>
             </a:endParaRPr>
-          </a:p>
-        </p:txBody>
-      </p:sp>
-    </p:spTree>
-    <p:extLst>
-      <p:ext uri="{BB962C8B-B14F-4D97-AF65-F5344CB8AC3E}">
-        <p14:creationId xmlns:p14="http://schemas.microsoft.com/office/powerpoint/2010/main" val="3016492598"/>
-      </p:ext>
-    </p:extLst>
-  </p:cSld>
-  <p:clrMapOvr>
-    <a:masterClrMapping/>
-  </p:clrMapOvr>
-  <mc:AlternateContent xmlns:mc="http://schemas.openxmlformats.org/markup-compatibility/2006">
-    <mc:Choice xmlns:p14="http://schemas.microsoft.com/office/powerpoint/2010/main" Requires="p14">
-      <p:transition spd="slow" p14:dur="2000"/>
-    </mc:Choice>
-    <mc:Fallback>
-      <p:transition spd="slow"/>
-    </mc:Fallback>
-  </mc:AlternateContent>
-</p:sld>
-</file>
-
-<file path=ppt/slides/slide9.xml><?xml version="1.0" encoding="utf-8"?>
-<p:sld xmlns:a="http://schemas.openxmlformats.org/drawingml/2006/main" xmlns:r="http://schemas.openxmlformats.org/officeDocument/2006/relationships" xmlns:p="http://schemas.openxmlformats.org/presentationml/2006/main" show="0">
-  <p:cSld>
-    <p:spTree>
-      <p:nvGrpSpPr>
-        <p:cNvPr id="1" name=""/>
-        <p:cNvGrpSpPr/>
-        <p:nvPr/>
-      </p:nvGrpSpPr>
-      <p:grpSpPr>
-        <a:xfrm>
-          <a:off x="0" y="0"/>
-          <a:ext cx="0" cy="0"/>
-          <a:chOff x="0" y="0"/>
-          <a:chExt cx="0" cy="0"/>
-        </a:xfrm>
-      </p:grpSpPr>
-      <p:sp>
-        <p:nvSpPr>
-          <p:cNvPr id="2" name="Título 1"/>
-          <p:cNvSpPr>
-            <a:spLocks noGrp="1"/>
-          </p:cNvSpPr>
-          <p:nvPr>
-            <p:ph type="title"/>
-          </p:nvPr>
-        </p:nvSpPr>
-        <p:spPr/>
-        <p:txBody>
-          <a:bodyPr/>
-          <a:lstStyle/>
-          <a:p>
-            <a:endParaRPr lang="en-US"/>
-          </a:p>
-        </p:txBody>
-      </p:sp>
-      <p:sp>
-        <p:nvSpPr>
-          <p:cNvPr id="3" name="Marcador de contenido 2"/>
-          <p:cNvSpPr>
-            <a:spLocks noGrp="1"/>
-          </p:cNvSpPr>
-          <p:nvPr>
-            <p:ph idx="1"/>
-          </p:nvPr>
-        </p:nvSpPr>
-        <p:spPr/>
-        <p:txBody>
-          <a:bodyPr/>
-          <a:lstStyle/>
-          <a:p>
-            <a:endParaRPr lang="en-US"/>
           </a:p>
         </p:txBody>
       </p:sp>
@@ -7230,116 +7556,38 @@
           </p:cNvPicPr>
           <p:nvPr/>
         </p:nvPicPr>
-        <p:blipFill>
-          <a:blip r:embed="rId2"/>
-          <a:stretch>
-            <a:fillRect/>
-          </a:stretch>
+        <p:blipFill rotWithShape="1">
+          <a:blip r:embed="rId3"/>
+          <a:srcRect l="521" t="16108" r="778" b="2220"/>
+          <a:stretch/>
         </p:blipFill>
         <p:spPr>
           <a:xfrm>
-            <a:off x="838200" y="519023"/>
-            <a:ext cx="10445471" cy="5819954"/>
+            <a:off x="-1" y="191387"/>
+            <a:ext cx="12525153" cy="5613990"/>
           </a:xfrm>
           <a:prstGeom prst="rect">
             <a:avLst/>
           </a:prstGeom>
         </p:spPr>
       </p:pic>
-      <p:sp>
-        <p:nvSpPr>
-          <p:cNvPr id="5" name="CuadroTexto 4"/>
-          <p:cNvSpPr txBox="1"/>
-          <p:nvPr/>
-        </p:nvSpPr>
-        <p:spPr>
-          <a:xfrm>
-            <a:off x="542925" y="365125"/>
-            <a:ext cx="2790825" cy="369332"/>
-          </a:xfrm>
-          <a:prstGeom prst="rect">
-            <a:avLst/>
-          </a:prstGeom>
-          <a:noFill/>
-        </p:spPr>
-        <p:txBody>
-          <a:bodyPr wrap="square" rtlCol="0">
-            <a:spAutoFit/>
-          </a:bodyPr>
-          <a:lstStyle/>
-          <a:p>
-            <a:r>
-              <a:rPr lang="es-MX" dirty="0" smtClean="0">
-                <a:solidFill>
-                  <a:srgbClr val="FF0000"/>
-                </a:solidFill>
-              </a:rPr>
-              <a:t>REVISANDO TODAVIA</a:t>
-            </a:r>
-            <a:endParaRPr lang="en-US" dirty="0">
-              <a:solidFill>
-                <a:srgbClr val="FF0000"/>
-              </a:solidFill>
-            </a:endParaRPr>
-          </a:p>
-        </p:txBody>
-      </p:sp>
-      <p:sp>
-        <p:nvSpPr>
-          <p:cNvPr id="6" name="CuadroTexto 5"/>
-          <p:cNvSpPr txBox="1"/>
-          <p:nvPr/>
-        </p:nvSpPr>
-        <p:spPr>
-          <a:xfrm>
-            <a:off x="838200" y="5115678"/>
-            <a:ext cx="10323647" cy="707886"/>
-          </a:xfrm>
-          <a:prstGeom prst="rect">
-            <a:avLst/>
-          </a:prstGeom>
-          <a:noFill/>
-        </p:spPr>
-        <p:txBody>
-          <a:bodyPr wrap="square" rtlCol="0">
-            <a:spAutoFit/>
-          </a:bodyPr>
-          <a:lstStyle/>
-          <a:p>
-            <a:r>
-              <a:rPr lang="es-MX" sz="4000" b="1" dirty="0" smtClean="0">
-                <a:solidFill>
-                  <a:srgbClr val="FF0000"/>
-                </a:solidFill>
-              </a:rPr>
-              <a:t>REVISANDO TODAVIA</a:t>
-            </a:r>
-            <a:endParaRPr lang="en-US" sz="4000" b="1" dirty="0">
-              <a:solidFill>
-                <a:srgbClr val="FF0000"/>
-              </a:solidFill>
-            </a:endParaRPr>
-          </a:p>
-        </p:txBody>
-      </p:sp>
     </p:spTree>
     <p:extLst>
       <p:ext uri="{BB962C8B-B14F-4D97-AF65-F5344CB8AC3E}">
-        <p14:creationId xmlns:p14="http://schemas.microsoft.com/office/powerpoint/2010/main" val="4084004493"/>
+        <p14:creationId xmlns:p14="http://schemas.microsoft.com/office/powerpoint/2010/main" val="635450468"/>
       </p:ext>
     </p:extLst>
   </p:cSld>
   <p:clrMapOvr>
     <a:masterClrMapping/>
   </p:clrMapOvr>
-  <mc:AlternateContent xmlns:mc="http://schemas.openxmlformats.org/markup-compatibility/2006">
-    <mc:Choice xmlns:p14="http://schemas.microsoft.com/office/powerpoint/2010/main" Requires="p14">
-      <p:transition spd="slow" p14:dur="2000"/>
-    </mc:Choice>
-    <mc:Fallback>
-      <p:transition spd="slow"/>
-    </mc:Fallback>
-  </mc:AlternateContent>
+  <p:timing>
+    <p:tnLst>
+      <p:par>
+        <p:cTn id="1" dur="indefinite" restart="never" nodeType="tmRoot"/>
+      </p:par>
+    </p:tnLst>
+  </p:timing>
 </p:sld>
 </file>
 

</xml_diff>